<commit_message>
Revisi slide 2: penggunaan AI mahasiswa dari bangun hingga tidur
Hook pembuka kini berupa linimasa sehari (05.30-22.30) yang mencakup
belajar, mobilitas, dan hiburan; PPTX cadangan dan kerangka diperbarui.

Co-Authored-By: Claude Opus 5.5 <noreply@anthropic.com>
Claude-Session: https://claude.ai/code/session_01JSBU28TonEdrikTyAmJbXP
</commit_message>
<xml_diff>
--- a/pptx/Seminar-Tren-Riset-AI.pptx
+++ b/pptx/Seminar-Tren-Riset-AI.pptx
@@ -1305,7 +1305,7 @@
           <a:lstStyle/>
           <a:p>
             <a:r>
-              <a:t>[1:00–2:30] Minta audiens angkat tangan/hitung. Tekankan: AI sudah menjadi infrastruktur tak terlihat. Kartu terakhir membuka benang merah cerita: kabut asap karhutla yang akrab bagi warga Riau. Pertanyaannya: bisakah AI membantu? Pertanyaan ini kita bawa sampai akhir.</a:t>
+              <a:t>[1:00–2:30] Ajak audiens menghitung berapa kartu yang mereka alami hari ini. Tekankan: dari belajar, mobilitas, hingga hiburan, AI sudah menjadi infrastruktur tak terlihat. Kartu terakhir adalah refleksi: kita sudah menjadi PENGGUNA AI sepanjang hari, kapan kita menjadi PEMBUAT solusi AI? Lalu buka benang merah cerita: "AI bisa memilihkan video untukmu, bisakah AI juga membantu mengatasi kabut asap di Riau?" Pertanyaan ini kita bawa sampai akhir.</a:t>
             </a:r>
           </a:p>
         </p:txBody>
@@ -13736,7 +13736,7 @@
         </p:nvSpPr>
         <p:spPr>
           <a:xfrm>
-            <a:off x="640080" y="1877060"/>
+            <a:off x="640080" y="1052576"/>
             <a:ext cx="10911535" cy="274320"/>
           </a:xfrm>
           <a:prstGeom prst="rect">
@@ -13758,7 +13758,7 @@
                 </a:solidFill>
                 <a:latin typeface="JetBrains Mono"/>
               </a:rPr>
-              <a:t>PERTANYAAN PEMBUKA</a:t>
+              <a:t>PERTANYAAN PEMBUKA · SEHARI BERSAMA AI</a:t>
             </a:r>
           </a:p>
         </p:txBody>
@@ -13771,8 +13771,8 @@
         </p:nvSpPr>
         <p:spPr>
           <a:xfrm>
-            <a:off x="640080" y="2242820"/>
-            <a:ext cx="10911535" cy="1122680"/>
+            <a:off x="640080" y="1418336"/>
+            <a:ext cx="10911535" cy="429260"/>
           </a:xfrm>
           <a:prstGeom prst="rect">
             <a:avLst/>
@@ -13787,28 +13787,16 @@
           <a:p>
             <a:pPr algn="l"/>
             <a:r>
-              <a:rPr sz="3400" b="1">
+              <a:rPr sz="2600" b="1">
                 <a:solidFill>
                   <a:srgbClr val="E8EEF8"/>
                 </a:solidFill>
                 <a:latin typeface="Plus Jakarta Sans"/>
               </a:rPr>
-              <a:t>Berapa kali kamu</a:t>
-            </a:r>
-          </a:p>
-          <a:p>
-            <a:pPr algn="l"/>
-            <a:r>
-              <a:rPr sz="3400" b="1">
-                <a:solidFill>
-                  <a:srgbClr val="E8EEF8"/>
-                </a:solidFill>
-                <a:latin typeface="Plus Jakarta Sans"/>
-              </a:rPr>
-              <a:t>menggunakan </a:t>
-            </a:r>
-            <a:r>
-              <a:rPr sz="3400" b="1">
+              <a:t>Berapa kali kamu menggunakan </a:t>
+            </a:r>
+            <a:r>
+              <a:rPr sz="2600" b="1">
                 <a:solidFill>
                   <a:srgbClr val="2DD4BF"/>
                 </a:solidFill>
@@ -13817,7 +13805,7 @@
               <a:t>AI</a:t>
             </a:r>
             <a:r>
-              <a:rPr sz="3400" b="1">
+              <a:rPr sz="2600" b="1">
                 <a:solidFill>
                   <a:srgbClr val="E8EEF8"/>
                 </a:solidFill>
@@ -13836,8 +13824,8 @@
         </p:nvSpPr>
         <p:spPr>
           <a:xfrm>
-            <a:off x="640080" y="3548380"/>
-            <a:ext cx="2577007" cy="1158240"/>
+            <a:off x="640080" y="2030476"/>
+            <a:ext cx="2577007" cy="1649730"/>
           </a:xfrm>
           <a:prstGeom prst="roundRect">
             <a:avLst>
@@ -13884,7 +13872,42 @@
         </p:nvSpPr>
         <p:spPr>
           <a:xfrm>
-            <a:off x="777240" y="3685540"/>
+            <a:off x="777240" y="2167636"/>
+            <a:ext cx="2302687" cy="274320"/>
+          </a:xfrm>
+          <a:prstGeom prst="rect">
+            <a:avLst/>
+          </a:prstGeom>
+          <a:noFill/>
+        </p:spPr>
+        <p:txBody>
+          <a:bodyPr wrap="square" anchor="t" lIns="45720" rIns="45720" tIns="18288" bIns="18288">
+            <a:spAutoFit/>
+          </a:bodyPr>
+          <a:lstStyle/>
+          <a:p>
+            <a:pPr algn="l"/>
+            <a:r>
+              <a:rPr sz="1200" b="0">
+                <a:solidFill>
+                  <a:srgbClr val="2DD4BF"/>
+                </a:solidFill>
+                <a:latin typeface="JetBrains Mono"/>
+              </a:rPr>
+              <a:t>05.30</a:t>
+            </a:r>
+          </a:p>
+        </p:txBody>
+      </p:sp>
+      <p:sp>
+        <p:nvSpPr>
+          <p:cNvPr id="6" name="TextBox 5"/>
+          <p:cNvSpPr txBox="1"/>
+          <p:nvPr/>
+        </p:nvSpPr>
+        <p:spPr>
+          <a:xfrm>
+            <a:off x="777240" y="2411476"/>
             <a:ext cx="2302687" cy="365760"/>
           </a:xfrm>
           <a:prstGeom prst="rect">
@@ -13906,20 +13929,20 @@
                 </a:solidFill>
                 <a:latin typeface="Plus Jakarta Sans"/>
               </a:rPr>
-              <a:t>Pagi</a:t>
-            </a:r>
-          </a:p>
-        </p:txBody>
-      </p:sp>
-      <p:sp>
-        <p:nvSpPr>
-          <p:cNvPr id="6" name="TextBox 5"/>
-          <p:cNvSpPr txBox="1"/>
-          <p:nvPr/>
-        </p:nvSpPr>
-        <p:spPr>
-          <a:xfrm>
-            <a:off x="777240" y="4028440"/>
+              <a:t>Bangun</a:t>
+            </a:r>
+          </a:p>
+        </p:txBody>
+      </p:sp>
+      <p:sp>
+        <p:nvSpPr>
+          <p:cNvPr id="7" name="TextBox 6"/>
+          <p:cNvSpPr txBox="1"/>
+          <p:nvPr/>
+        </p:nvSpPr>
+        <p:spPr>
+          <a:xfrm>
+            <a:off x="777240" y="2754376"/>
             <a:ext cx="2302687" cy="457200"/>
           </a:xfrm>
           <a:prstGeom prst="rect">
@@ -13941,21 +13964,21 @@
                 </a:solidFill>
                 <a:latin typeface="Plus Jakarta Sans"/>
               </a:rPr>
-              <a:t>Rekomendasi video &amp; berita</a:t>
-            </a:r>
-          </a:p>
-        </p:txBody>
-      </p:sp>
-      <p:sp>
-        <p:nvSpPr>
-          <p:cNvPr id="7" name="Rounded Rectangle 6"/>
+              <a:t>Alarm pintar &amp; pelacak tidur smartwatch</a:t>
+            </a:r>
+          </a:p>
+        </p:txBody>
+      </p:sp>
+      <p:sp>
+        <p:nvSpPr>
+          <p:cNvPr id="8" name="Rounded Rectangle 7"/>
           <p:cNvSpPr/>
           <p:nvPr/>
         </p:nvSpPr>
         <p:spPr>
           <a:xfrm>
-            <a:off x="3418255" y="3548380"/>
-            <a:ext cx="2577007" cy="1158240"/>
+            <a:off x="3418255" y="2030476"/>
+            <a:ext cx="2577007" cy="1649730"/>
           </a:xfrm>
           <a:prstGeom prst="roundRect">
             <a:avLst>
@@ -13996,13 +14019,48 @@
       </p:sp>
       <p:sp>
         <p:nvSpPr>
-          <p:cNvPr id="8" name="TextBox 7"/>
-          <p:cNvSpPr txBox="1"/>
-          <p:nvPr/>
-        </p:nvSpPr>
-        <p:spPr>
-          <a:xfrm>
-            <a:off x="3555415" y="3685540"/>
+          <p:cNvPr id="9" name="TextBox 8"/>
+          <p:cNvSpPr txBox="1"/>
+          <p:nvPr/>
+        </p:nvSpPr>
+        <p:spPr>
+          <a:xfrm>
+            <a:off x="3555415" y="2167636"/>
+            <a:ext cx="2302687" cy="274320"/>
+          </a:xfrm>
+          <a:prstGeom prst="rect">
+            <a:avLst/>
+          </a:prstGeom>
+          <a:noFill/>
+        </p:spPr>
+        <p:txBody>
+          <a:bodyPr wrap="square" anchor="t" lIns="45720" rIns="45720" tIns="18288" bIns="18288">
+            <a:spAutoFit/>
+          </a:bodyPr>
+          <a:lstStyle/>
+          <a:p>
+            <a:pPr algn="l"/>
+            <a:r>
+              <a:rPr sz="1200" b="0">
+                <a:solidFill>
+                  <a:srgbClr val="2DD4BF"/>
+                </a:solidFill>
+                <a:latin typeface="JetBrains Mono"/>
+              </a:rPr>
+              <a:t>06.30</a:t>
+            </a:r>
+          </a:p>
+        </p:txBody>
+      </p:sp>
+      <p:sp>
+        <p:nvSpPr>
+          <p:cNvPr id="10" name="TextBox 9"/>
+          <p:cNvSpPr txBox="1"/>
+          <p:nvPr/>
+        </p:nvSpPr>
+        <p:spPr>
+          <a:xfrm>
+            <a:off x="3555415" y="2411476"/>
             <a:ext cx="2302687" cy="365760"/>
           </a:xfrm>
           <a:prstGeom prst="rect">
@@ -14024,20 +14082,20 @@
                 </a:solidFill>
                 <a:latin typeface="Plus Jakarta Sans"/>
               </a:rPr>
-              <a:t>Kuliah</a:t>
-            </a:r>
-          </a:p>
-        </p:txBody>
-      </p:sp>
-      <p:sp>
-        <p:nvSpPr>
-          <p:cNvPr id="9" name="TextBox 8"/>
-          <p:cNvSpPr txBox="1"/>
-          <p:nvPr/>
-        </p:nvSpPr>
-        <p:spPr>
-          <a:xfrm>
-            <a:off x="3555415" y="4028440"/>
+              <a:t>Bersiap</a:t>
+            </a:r>
+          </a:p>
+        </p:txBody>
+      </p:sp>
+      <p:sp>
+        <p:nvSpPr>
+          <p:cNvPr id="11" name="TextBox 10"/>
+          <p:cNvSpPr txBox="1"/>
+          <p:nvPr/>
+        </p:nvSpPr>
+        <p:spPr>
+          <a:xfrm>
+            <a:off x="3555415" y="2754376"/>
             <a:ext cx="2302687" cy="457200"/>
           </a:xfrm>
           <a:prstGeom prst="rect">
@@ -14059,21 +14117,21 @@
                 </a:solidFill>
                 <a:latin typeface="Plus Jakarta Sans"/>
               </a:rPr>
-              <a:t>Terjemahan, ringkasan, ChatGPT</a:t>
-            </a:r>
-          </a:p>
-        </p:txBody>
-      </p:sp>
-      <p:sp>
-        <p:nvSpPr>
-          <p:cNvPr id="10" name="Rounded Rectangle 9"/>
+              <a:t>Asisten suara: cuaca &amp; jadwal kuliah</a:t>
+            </a:r>
+          </a:p>
+        </p:txBody>
+      </p:sp>
+      <p:sp>
+        <p:nvSpPr>
+          <p:cNvPr id="12" name="Rounded Rectangle 11"/>
           <p:cNvSpPr/>
           <p:nvPr/>
         </p:nvSpPr>
         <p:spPr>
           <a:xfrm>
-            <a:off x="6196431" y="3548380"/>
-            <a:ext cx="2577007" cy="1158240"/>
+            <a:off x="6196431" y="2030476"/>
+            <a:ext cx="2577007" cy="1649730"/>
           </a:xfrm>
           <a:prstGeom prst="roundRect">
             <a:avLst>
@@ -14114,13 +14172,48 @@
       </p:sp>
       <p:sp>
         <p:nvSpPr>
-          <p:cNvPr id="11" name="TextBox 10"/>
-          <p:cNvSpPr txBox="1"/>
-          <p:nvPr/>
-        </p:nvSpPr>
-        <p:spPr>
-          <a:xfrm>
-            <a:off x="6333591" y="3685540"/>
+          <p:cNvPr id="13" name="TextBox 12"/>
+          <p:cNvSpPr txBox="1"/>
+          <p:nvPr/>
+        </p:nvSpPr>
+        <p:spPr>
+          <a:xfrm>
+            <a:off x="6333591" y="2167636"/>
+            <a:ext cx="2302687" cy="274320"/>
+          </a:xfrm>
+          <a:prstGeom prst="rect">
+            <a:avLst/>
+          </a:prstGeom>
+          <a:noFill/>
+        </p:spPr>
+        <p:txBody>
+          <a:bodyPr wrap="square" anchor="t" lIns="45720" rIns="45720" tIns="18288" bIns="18288">
+            <a:spAutoFit/>
+          </a:bodyPr>
+          <a:lstStyle/>
+          <a:p>
+            <a:pPr algn="l"/>
+            <a:r>
+              <a:rPr sz="1200" b="0">
+                <a:solidFill>
+                  <a:srgbClr val="2DD4BF"/>
+                </a:solidFill>
+                <a:latin typeface="JetBrains Mono"/>
+              </a:rPr>
+              <a:t>07.15</a:t>
+            </a:r>
+          </a:p>
+        </p:txBody>
+      </p:sp>
+      <p:sp>
+        <p:nvSpPr>
+          <p:cNvPr id="14" name="TextBox 13"/>
+          <p:cNvSpPr txBox="1"/>
+          <p:nvPr/>
+        </p:nvSpPr>
+        <p:spPr>
+          <a:xfrm>
+            <a:off x="6333591" y="2411476"/>
             <a:ext cx="2302687" cy="365760"/>
           </a:xfrm>
           <a:prstGeom prst="rect">
@@ -14142,20 +14235,20 @@
                 </a:solidFill>
                 <a:latin typeface="Plus Jakarta Sans"/>
               </a:rPr>
-              <a:t>Jalan</a:t>
-            </a:r>
-          </a:p>
-        </p:txBody>
-      </p:sp>
-      <p:sp>
-        <p:nvSpPr>
-          <p:cNvPr id="12" name="TextBox 11"/>
-          <p:cNvSpPr txBox="1"/>
-          <p:nvPr/>
-        </p:nvSpPr>
-        <p:spPr>
-          <a:xfrm>
-            <a:off x="6333591" y="4028440"/>
+              <a:t>Berangkat</a:t>
+            </a:r>
+          </a:p>
+        </p:txBody>
+      </p:sp>
+      <p:sp>
+        <p:nvSpPr>
+          <p:cNvPr id="15" name="TextBox 14"/>
+          <p:cNvSpPr txBox="1"/>
+          <p:nvPr/>
+        </p:nvSpPr>
+        <p:spPr>
+          <a:xfrm>
+            <a:off x="6333591" y="2754376"/>
             <a:ext cx="2302687" cy="457200"/>
           </a:xfrm>
           <a:prstGeom prst="rect">
@@ -14177,21 +14270,633 @@
                 </a:solidFill>
                 <a:latin typeface="Plus Jakarta Sans"/>
               </a:rPr>
-              <a:t>Maps memprediksi macet</a:t>
-            </a:r>
-          </a:p>
-        </p:txBody>
-      </p:sp>
-      <p:sp>
-        <p:nvSpPr>
-          <p:cNvPr id="13" name="Rounded Rectangle 12"/>
+              <a:t>Maps, Gojek/Grab: prediksi macet, rute &amp; tarif</a:t>
+            </a:r>
+          </a:p>
+        </p:txBody>
+      </p:sp>
+      <p:sp>
+        <p:nvSpPr>
+          <p:cNvPr id="16" name="Rounded Rectangle 15"/>
           <p:cNvSpPr/>
           <p:nvPr/>
         </p:nvSpPr>
         <p:spPr>
           <a:xfrm>
-            <a:off x="8974607" y="3548380"/>
-            <a:ext cx="2577007" cy="1158240"/>
+            <a:off x="8974607" y="2030476"/>
+            <a:ext cx="2577007" cy="1649730"/>
+          </a:xfrm>
+          <a:prstGeom prst="roundRect">
+            <a:avLst>
+              <a:gd name="adj" fmla="val 8000"/>
+            </a:avLst>
+          </a:prstGeom>
+          <a:solidFill>
+            <a:srgbClr val="172A4A"/>
+          </a:solidFill>
+          <a:ln w="15875">
+            <a:solidFill>
+              <a:srgbClr val="2A4268"/>
+            </a:solidFill>
+          </a:ln>
+          <a:effectLst/>
+        </p:spPr>
+        <p:style>
+          <a:lnRef idx="1">
+            <a:schemeClr val="accent1"/>
+          </a:lnRef>
+          <a:fillRef idx="3">
+            <a:schemeClr val="accent1"/>
+          </a:fillRef>
+          <a:effectRef idx="2">
+            <a:schemeClr val="accent1"/>
+          </a:effectRef>
+          <a:fontRef idx="minor">
+            <a:schemeClr val="lt1"/>
+          </a:fontRef>
+        </p:style>
+        <p:txBody>
+          <a:bodyPr rtlCol="0" anchor="ctr"/>
+          <a:lstStyle/>
+          <a:p>
+            <a:pPr algn="ctr"/>
+          </a:p>
+        </p:txBody>
+      </p:sp>
+      <p:sp>
+        <p:nvSpPr>
+          <p:cNvPr id="17" name="TextBox 16"/>
+          <p:cNvSpPr txBox="1"/>
+          <p:nvPr/>
+        </p:nvSpPr>
+        <p:spPr>
+          <a:xfrm>
+            <a:off x="9111767" y="2167636"/>
+            <a:ext cx="2302687" cy="274320"/>
+          </a:xfrm>
+          <a:prstGeom prst="rect">
+            <a:avLst/>
+          </a:prstGeom>
+          <a:noFill/>
+        </p:spPr>
+        <p:txBody>
+          <a:bodyPr wrap="square" anchor="t" lIns="45720" rIns="45720" tIns="18288" bIns="18288">
+            <a:spAutoFit/>
+          </a:bodyPr>
+          <a:lstStyle/>
+          <a:p>
+            <a:pPr algn="l"/>
+            <a:r>
+              <a:rPr sz="1200" b="0">
+                <a:solidFill>
+                  <a:srgbClr val="2DD4BF"/>
+                </a:solidFill>
+                <a:latin typeface="JetBrains Mono"/>
+              </a:rPr>
+              <a:t>08.00</a:t>
+            </a:r>
+          </a:p>
+        </p:txBody>
+      </p:sp>
+      <p:sp>
+        <p:nvSpPr>
+          <p:cNvPr id="18" name="TextBox 17"/>
+          <p:cNvSpPr txBox="1"/>
+          <p:nvPr/>
+        </p:nvSpPr>
+        <p:spPr>
+          <a:xfrm>
+            <a:off x="9111767" y="2411476"/>
+            <a:ext cx="2302687" cy="365760"/>
+          </a:xfrm>
+          <a:prstGeom prst="rect">
+            <a:avLst/>
+          </a:prstGeom>
+          <a:noFill/>
+        </p:spPr>
+        <p:txBody>
+          <a:bodyPr wrap="square" anchor="t" lIns="45720" rIns="45720" tIns="18288" bIns="18288">
+            <a:spAutoFit/>
+          </a:bodyPr>
+          <a:lstStyle/>
+          <a:p>
+            <a:pPr algn="l"/>
+            <a:r>
+              <a:rPr sz="1800" b="1">
+                <a:solidFill>
+                  <a:srgbClr val="E8EEF8"/>
+                </a:solidFill>
+                <a:latin typeface="Plus Jakarta Sans"/>
+              </a:rPr>
+              <a:t>Kuliah</a:t>
+            </a:r>
+          </a:p>
+        </p:txBody>
+      </p:sp>
+      <p:sp>
+        <p:nvSpPr>
+          <p:cNvPr id="19" name="TextBox 18"/>
+          <p:cNvSpPr txBox="1"/>
+          <p:nvPr/>
+        </p:nvSpPr>
+        <p:spPr>
+          <a:xfrm>
+            <a:off x="9111767" y="2754376"/>
+            <a:ext cx="2302687" cy="457200"/>
+          </a:xfrm>
+          <a:prstGeom prst="rect">
+            <a:avLst/>
+          </a:prstGeom>
+          <a:noFill/>
+        </p:spPr>
+        <p:txBody>
+          <a:bodyPr wrap="square" anchor="t" lIns="45720" rIns="45720" tIns="18288" bIns="18288">
+            <a:spAutoFit/>
+          </a:bodyPr>
+          <a:lstStyle/>
+          <a:p>
+            <a:pPr algn="l"/>
+            <a:r>
+              <a:rPr sz="1500" b="0">
+                <a:solidFill>
+                  <a:srgbClr val="9FB2CF"/>
+                </a:solidFill>
+                <a:latin typeface="Plus Jakarta Sans"/>
+              </a:rPr>
+              <a:t>ChatGPT/Gemini meringkas materi, Translate, Grammarly</a:t>
+            </a:r>
+          </a:p>
+        </p:txBody>
+      </p:sp>
+      <p:sp>
+        <p:nvSpPr>
+          <p:cNvPr id="20" name="Rounded Rectangle 19"/>
+          <p:cNvSpPr/>
+          <p:nvPr/>
+        </p:nvSpPr>
+        <p:spPr>
+          <a:xfrm>
+            <a:off x="640080" y="3881374"/>
+            <a:ext cx="2577007" cy="1649730"/>
+          </a:xfrm>
+          <a:prstGeom prst="roundRect">
+            <a:avLst>
+              <a:gd name="adj" fmla="val 8000"/>
+            </a:avLst>
+          </a:prstGeom>
+          <a:solidFill>
+            <a:srgbClr val="172A4A"/>
+          </a:solidFill>
+          <a:ln w="15875">
+            <a:solidFill>
+              <a:srgbClr val="2A4268"/>
+            </a:solidFill>
+          </a:ln>
+          <a:effectLst/>
+        </p:spPr>
+        <p:style>
+          <a:lnRef idx="1">
+            <a:schemeClr val="accent1"/>
+          </a:lnRef>
+          <a:fillRef idx="3">
+            <a:schemeClr val="accent1"/>
+          </a:fillRef>
+          <a:effectRef idx="2">
+            <a:schemeClr val="accent1"/>
+          </a:effectRef>
+          <a:fontRef idx="minor">
+            <a:schemeClr val="lt1"/>
+          </a:fontRef>
+        </p:style>
+        <p:txBody>
+          <a:bodyPr rtlCol="0" anchor="ctr"/>
+          <a:lstStyle/>
+          <a:p>
+            <a:pPr algn="ctr"/>
+          </a:p>
+        </p:txBody>
+      </p:sp>
+      <p:sp>
+        <p:nvSpPr>
+          <p:cNvPr id="21" name="TextBox 20"/>
+          <p:cNvSpPr txBox="1"/>
+          <p:nvPr/>
+        </p:nvSpPr>
+        <p:spPr>
+          <a:xfrm>
+            <a:off x="777240" y="4018534"/>
+            <a:ext cx="2302687" cy="274320"/>
+          </a:xfrm>
+          <a:prstGeom prst="rect">
+            <a:avLst/>
+          </a:prstGeom>
+          <a:noFill/>
+        </p:spPr>
+        <p:txBody>
+          <a:bodyPr wrap="square" anchor="t" lIns="45720" rIns="45720" tIns="18288" bIns="18288">
+            <a:spAutoFit/>
+          </a:bodyPr>
+          <a:lstStyle/>
+          <a:p>
+            <a:pPr algn="l"/>
+            <a:r>
+              <a:rPr sz="1200" b="0">
+                <a:solidFill>
+                  <a:srgbClr val="2DD4BF"/>
+                </a:solidFill>
+                <a:latin typeface="JetBrains Mono"/>
+              </a:rPr>
+              <a:t>12.00</a:t>
+            </a:r>
+          </a:p>
+        </p:txBody>
+      </p:sp>
+      <p:sp>
+        <p:nvSpPr>
+          <p:cNvPr id="22" name="TextBox 21"/>
+          <p:cNvSpPr txBox="1"/>
+          <p:nvPr/>
+        </p:nvSpPr>
+        <p:spPr>
+          <a:xfrm>
+            <a:off x="777240" y="4262374"/>
+            <a:ext cx="2302687" cy="365760"/>
+          </a:xfrm>
+          <a:prstGeom prst="rect">
+            <a:avLst/>
+          </a:prstGeom>
+          <a:noFill/>
+        </p:spPr>
+        <p:txBody>
+          <a:bodyPr wrap="square" anchor="t" lIns="45720" rIns="45720" tIns="18288" bIns="18288">
+            <a:spAutoFit/>
+          </a:bodyPr>
+          <a:lstStyle/>
+          <a:p>
+            <a:pPr algn="l"/>
+            <a:r>
+              <a:rPr sz="1800" b="1">
+                <a:solidFill>
+                  <a:srgbClr val="E8EEF8"/>
+                </a:solidFill>
+                <a:latin typeface="Plus Jakarta Sans"/>
+              </a:rPr>
+              <a:t>Istirahat</a:t>
+            </a:r>
+          </a:p>
+        </p:txBody>
+      </p:sp>
+      <p:sp>
+        <p:nvSpPr>
+          <p:cNvPr id="23" name="TextBox 22"/>
+          <p:cNvSpPr txBox="1"/>
+          <p:nvPr/>
+        </p:nvSpPr>
+        <p:spPr>
+          <a:xfrm>
+            <a:off x="777240" y="4605274"/>
+            <a:ext cx="2302687" cy="457200"/>
+          </a:xfrm>
+          <a:prstGeom prst="rect">
+            <a:avLst/>
+          </a:prstGeom>
+          <a:noFill/>
+        </p:spPr>
+        <p:txBody>
+          <a:bodyPr wrap="square" anchor="t" lIns="45720" rIns="45720" tIns="18288" bIns="18288">
+            <a:spAutoFit/>
+          </a:bodyPr>
+          <a:lstStyle/>
+          <a:p>
+            <a:pPr algn="l"/>
+            <a:r>
+              <a:rPr sz="1500" b="0">
+                <a:solidFill>
+                  <a:srgbClr val="9FB2CF"/>
+                </a:solidFill>
+                <a:latin typeface="Plus Jakarta Sans"/>
+              </a:rPr>
+              <a:t>Rekomendasi GoFood, Face ID &amp; deteksi fraud e-wallet</a:t>
+            </a:r>
+          </a:p>
+        </p:txBody>
+      </p:sp>
+      <p:sp>
+        <p:nvSpPr>
+          <p:cNvPr id="24" name="Rounded Rectangle 23"/>
+          <p:cNvSpPr/>
+          <p:nvPr/>
+        </p:nvSpPr>
+        <p:spPr>
+          <a:xfrm>
+            <a:off x="3418255" y="3881374"/>
+            <a:ext cx="2577007" cy="1649730"/>
+          </a:xfrm>
+          <a:prstGeom prst="roundRect">
+            <a:avLst>
+              <a:gd name="adj" fmla="val 8000"/>
+            </a:avLst>
+          </a:prstGeom>
+          <a:solidFill>
+            <a:srgbClr val="172A4A"/>
+          </a:solidFill>
+          <a:ln w="15875">
+            <a:solidFill>
+              <a:srgbClr val="2A4268"/>
+            </a:solidFill>
+          </a:ln>
+          <a:effectLst/>
+        </p:spPr>
+        <p:style>
+          <a:lnRef idx="1">
+            <a:schemeClr val="accent1"/>
+          </a:lnRef>
+          <a:fillRef idx="3">
+            <a:schemeClr val="accent1"/>
+          </a:fillRef>
+          <a:effectRef idx="2">
+            <a:schemeClr val="accent1"/>
+          </a:effectRef>
+          <a:fontRef idx="minor">
+            <a:schemeClr val="lt1"/>
+          </a:fontRef>
+        </p:style>
+        <p:txBody>
+          <a:bodyPr rtlCol="0" anchor="ctr"/>
+          <a:lstStyle/>
+          <a:p>
+            <a:pPr algn="ctr"/>
+          </a:p>
+        </p:txBody>
+      </p:sp>
+      <p:sp>
+        <p:nvSpPr>
+          <p:cNvPr id="25" name="TextBox 24"/>
+          <p:cNvSpPr txBox="1"/>
+          <p:nvPr/>
+        </p:nvSpPr>
+        <p:spPr>
+          <a:xfrm>
+            <a:off x="3555415" y="4018534"/>
+            <a:ext cx="2302687" cy="274320"/>
+          </a:xfrm>
+          <a:prstGeom prst="rect">
+            <a:avLst/>
+          </a:prstGeom>
+          <a:noFill/>
+        </p:spPr>
+        <p:txBody>
+          <a:bodyPr wrap="square" anchor="t" lIns="45720" rIns="45720" tIns="18288" bIns="18288">
+            <a:spAutoFit/>
+          </a:bodyPr>
+          <a:lstStyle/>
+          <a:p>
+            <a:pPr algn="l"/>
+            <a:r>
+              <a:rPr sz="1200" b="0">
+                <a:solidFill>
+                  <a:srgbClr val="2DD4BF"/>
+                </a:solidFill>
+                <a:latin typeface="JetBrains Mono"/>
+              </a:rPr>
+              <a:t>15.00</a:t>
+            </a:r>
+          </a:p>
+        </p:txBody>
+      </p:sp>
+      <p:sp>
+        <p:nvSpPr>
+          <p:cNvPr id="26" name="TextBox 25"/>
+          <p:cNvSpPr txBox="1"/>
+          <p:nvPr/>
+        </p:nvSpPr>
+        <p:spPr>
+          <a:xfrm>
+            <a:off x="3555415" y="4262374"/>
+            <a:ext cx="2302687" cy="365760"/>
+          </a:xfrm>
+          <a:prstGeom prst="rect">
+            <a:avLst/>
+          </a:prstGeom>
+          <a:noFill/>
+        </p:spPr>
+        <p:txBody>
+          <a:bodyPr wrap="square" anchor="t" lIns="45720" rIns="45720" tIns="18288" bIns="18288">
+            <a:spAutoFit/>
+          </a:bodyPr>
+          <a:lstStyle/>
+          <a:p>
+            <a:pPr algn="l"/>
+            <a:r>
+              <a:rPr sz="1800" b="1">
+                <a:solidFill>
+                  <a:srgbClr val="E8EEF8"/>
+                </a:solidFill>
+                <a:latin typeface="Plus Jakarta Sans"/>
+              </a:rPr>
+              <a:t>Tugas &amp; Riset</a:t>
+            </a:r>
+          </a:p>
+        </p:txBody>
+      </p:sp>
+      <p:sp>
+        <p:nvSpPr>
+          <p:cNvPr id="27" name="TextBox 26"/>
+          <p:cNvSpPr txBox="1"/>
+          <p:nvPr/>
+        </p:nvSpPr>
+        <p:spPr>
+          <a:xfrm>
+            <a:off x="3555415" y="4605274"/>
+            <a:ext cx="2302687" cy="457200"/>
+          </a:xfrm>
+          <a:prstGeom prst="rect">
+            <a:avLst/>
+          </a:prstGeom>
+          <a:noFill/>
+        </p:spPr>
+        <p:txBody>
+          <a:bodyPr wrap="square" anchor="t" lIns="45720" rIns="45720" tIns="18288" bIns="18288">
+            <a:spAutoFit/>
+          </a:bodyPr>
+          <a:lstStyle/>
+          <a:p>
+            <a:pPr algn="l"/>
+            <a:r>
+              <a:rPr sz="1500" b="0">
+                <a:solidFill>
+                  <a:srgbClr val="9FB2CF"/>
+                </a:solidFill>
+                <a:latin typeface="Plus Jakarta Sans"/>
+              </a:rPr>
+              <a:t>GitHub Copilot, Perplexity/Elicit, NotebookLM</a:t>
+            </a:r>
+          </a:p>
+        </p:txBody>
+      </p:sp>
+      <p:sp>
+        <p:nvSpPr>
+          <p:cNvPr id="28" name="Rounded Rectangle 27"/>
+          <p:cNvSpPr/>
+          <p:nvPr/>
+        </p:nvSpPr>
+        <p:spPr>
+          <a:xfrm>
+            <a:off x="6196431" y="3881374"/>
+            <a:ext cx="2577007" cy="1649730"/>
+          </a:xfrm>
+          <a:prstGeom prst="roundRect">
+            <a:avLst>
+              <a:gd name="adj" fmla="val 8000"/>
+            </a:avLst>
+          </a:prstGeom>
+          <a:solidFill>
+            <a:srgbClr val="172A4A"/>
+          </a:solidFill>
+          <a:ln w="15875">
+            <a:solidFill>
+              <a:srgbClr val="2A4268"/>
+            </a:solidFill>
+          </a:ln>
+          <a:effectLst/>
+        </p:spPr>
+        <p:style>
+          <a:lnRef idx="1">
+            <a:schemeClr val="accent1"/>
+          </a:lnRef>
+          <a:fillRef idx="3">
+            <a:schemeClr val="accent1"/>
+          </a:fillRef>
+          <a:effectRef idx="2">
+            <a:schemeClr val="accent1"/>
+          </a:effectRef>
+          <a:fontRef idx="minor">
+            <a:schemeClr val="lt1"/>
+          </a:fontRef>
+        </p:style>
+        <p:txBody>
+          <a:bodyPr rtlCol="0" anchor="ctr"/>
+          <a:lstStyle/>
+          <a:p>
+            <a:pPr algn="ctr"/>
+          </a:p>
+        </p:txBody>
+      </p:sp>
+      <p:sp>
+        <p:nvSpPr>
+          <p:cNvPr id="29" name="TextBox 28"/>
+          <p:cNvSpPr txBox="1"/>
+          <p:nvPr/>
+        </p:nvSpPr>
+        <p:spPr>
+          <a:xfrm>
+            <a:off x="6333591" y="4018534"/>
+            <a:ext cx="2302687" cy="274320"/>
+          </a:xfrm>
+          <a:prstGeom prst="rect">
+            <a:avLst/>
+          </a:prstGeom>
+          <a:noFill/>
+        </p:spPr>
+        <p:txBody>
+          <a:bodyPr wrap="square" anchor="t" lIns="45720" rIns="45720" tIns="18288" bIns="18288">
+            <a:spAutoFit/>
+          </a:bodyPr>
+          <a:lstStyle/>
+          <a:p>
+            <a:pPr algn="l"/>
+            <a:r>
+              <a:rPr sz="1200" b="0">
+                <a:solidFill>
+                  <a:srgbClr val="2DD4BF"/>
+                </a:solidFill>
+                <a:latin typeface="JetBrains Mono"/>
+              </a:rPr>
+              <a:t>19.00</a:t>
+            </a:r>
+          </a:p>
+        </p:txBody>
+      </p:sp>
+      <p:sp>
+        <p:nvSpPr>
+          <p:cNvPr id="30" name="TextBox 29"/>
+          <p:cNvSpPr txBox="1"/>
+          <p:nvPr/>
+        </p:nvSpPr>
+        <p:spPr>
+          <a:xfrm>
+            <a:off x="6333591" y="4262374"/>
+            <a:ext cx="2302687" cy="365760"/>
+          </a:xfrm>
+          <a:prstGeom prst="rect">
+            <a:avLst/>
+          </a:prstGeom>
+          <a:noFill/>
+        </p:spPr>
+        <p:txBody>
+          <a:bodyPr wrap="square" anchor="t" lIns="45720" rIns="45720" tIns="18288" bIns="18288">
+            <a:spAutoFit/>
+          </a:bodyPr>
+          <a:lstStyle/>
+          <a:p>
+            <a:pPr algn="l"/>
+            <a:r>
+              <a:rPr sz="1800" b="1">
+                <a:solidFill>
+                  <a:srgbClr val="E8EEF8"/>
+                </a:solidFill>
+                <a:latin typeface="Plus Jakarta Sans"/>
+              </a:rPr>
+              <a:t>Hiburan</a:t>
+            </a:r>
+          </a:p>
+        </p:txBody>
+      </p:sp>
+      <p:sp>
+        <p:nvSpPr>
+          <p:cNvPr id="31" name="TextBox 30"/>
+          <p:cNvSpPr txBox="1"/>
+          <p:nvPr/>
+        </p:nvSpPr>
+        <p:spPr>
+          <a:xfrm>
+            <a:off x="6333591" y="4605274"/>
+            <a:ext cx="2302687" cy="457200"/>
+          </a:xfrm>
+          <a:prstGeom prst="rect">
+            <a:avLst/>
+          </a:prstGeom>
+          <a:noFill/>
+        </p:spPr>
+        <p:txBody>
+          <a:bodyPr wrap="square" anchor="t" lIns="45720" rIns="45720" tIns="18288" bIns="18288">
+            <a:spAutoFit/>
+          </a:bodyPr>
+          <a:lstStyle/>
+          <a:p>
+            <a:pPr algn="l"/>
+            <a:r>
+              <a:rPr sz="1500" b="0">
+                <a:solidFill>
+                  <a:srgbClr val="9FB2CF"/>
+                </a:solidFill>
+                <a:latin typeface="Plus Jakarta Sans"/>
+              </a:rPr>
+              <a:t>Rekomendasi TikTok, YouTube, Spotify, Netflix, filter AR</a:t>
+            </a:r>
+          </a:p>
+        </p:txBody>
+      </p:sp>
+      <p:sp>
+        <p:nvSpPr>
+          <p:cNvPr id="32" name="Rounded Rectangle 31"/>
+          <p:cNvSpPr/>
+          <p:nvPr/>
+        </p:nvSpPr>
+        <p:spPr>
+          <a:xfrm>
+            <a:off x="8974607" y="3881374"/>
+            <a:ext cx="2577007" cy="1649730"/>
           </a:xfrm>
           <a:prstGeom prst="roundRect">
             <a:avLst>
@@ -14232,13 +14937,48 @@
       </p:sp>
       <p:sp>
         <p:nvSpPr>
-          <p:cNvPr id="14" name="TextBox 13"/>
-          <p:cNvSpPr txBox="1"/>
-          <p:nvPr/>
-        </p:nvSpPr>
-        <p:spPr>
-          <a:xfrm>
-            <a:off x="9111767" y="3685540"/>
+          <p:cNvPr id="33" name="TextBox 32"/>
+          <p:cNvSpPr txBox="1"/>
+          <p:nvPr/>
+        </p:nvSpPr>
+        <p:spPr>
+          <a:xfrm>
+            <a:off x="9111767" y="4018534"/>
+            <a:ext cx="2302687" cy="274320"/>
+          </a:xfrm>
+          <a:prstGeom prst="rect">
+            <a:avLst/>
+          </a:prstGeom>
+          <a:noFill/>
+        </p:spPr>
+        <p:txBody>
+          <a:bodyPr wrap="square" anchor="t" lIns="45720" rIns="45720" tIns="18288" bIns="18288">
+            <a:spAutoFit/>
+          </a:bodyPr>
+          <a:lstStyle/>
+          <a:p>
+            <a:pPr algn="l"/>
+            <a:r>
+              <a:rPr sz="1200" b="0">
+                <a:solidFill>
+                  <a:srgbClr val="2DD4BF"/>
+                </a:solidFill>
+                <a:latin typeface="JetBrains Mono"/>
+              </a:rPr>
+              <a:t>22.30</a:t>
+            </a:r>
+          </a:p>
+        </p:txBody>
+      </p:sp>
+      <p:sp>
+        <p:nvSpPr>
+          <p:cNvPr id="34" name="TextBox 33"/>
+          <p:cNvSpPr txBox="1"/>
+          <p:nvPr/>
+        </p:nvSpPr>
+        <p:spPr>
+          <a:xfrm>
+            <a:off x="9111767" y="4262374"/>
             <a:ext cx="2302687" cy="365760"/>
           </a:xfrm>
           <a:prstGeom prst="rect">
@@ -14260,20 +15000,20 @@
                 </a:solidFill>
                 <a:latin typeface="Plus Jakarta Sans"/>
               </a:rPr>
-              <a:t>Riau</a:t>
-            </a:r>
-          </a:p>
-        </p:txBody>
-      </p:sp>
-      <p:sp>
-        <p:nvSpPr>
-          <p:cNvPr id="15" name="TextBox 14"/>
-          <p:cNvSpPr txBox="1"/>
-          <p:nvPr/>
-        </p:nvSpPr>
-        <p:spPr>
-          <a:xfrm>
-            <a:off x="9111767" y="4028440"/>
+              <a:t>Menjelang tidur</a:t>
+            </a:r>
+          </a:p>
+        </p:txBody>
+      </p:sp>
+      <p:sp>
+        <p:nvSpPr>
+          <p:cNvPr id="35" name="TextBox 34"/>
+          <p:cNvSpPr txBox="1"/>
+          <p:nvPr/>
+        </p:nvSpPr>
+        <p:spPr>
+          <a:xfrm>
+            <a:off x="9111767" y="4605274"/>
             <a:ext cx="2302687" cy="457200"/>
           </a:xfrm>
           <a:prstGeom prst="rect">
@@ -14295,14 +15035,14 @@
                 </a:solidFill>
                 <a:latin typeface="Plus Jakarta Sans"/>
               </a:rPr>
-              <a:t>Satelit memantau titik api</a:t>
-            </a:r>
-          </a:p>
-        </p:txBody>
-      </p:sp>
-      <p:sp>
-        <p:nvSpPr>
-          <p:cNvPr id="16" name="TextBox 15"/>
+              <a:t>Feed media sosial dikurasi AI, Duolingo, mode tidur</a:t>
+            </a:r>
+          </a:p>
+        </p:txBody>
+      </p:sp>
+      <p:sp>
+        <p:nvSpPr>
+          <p:cNvPr id="36" name="TextBox 35"/>
           <p:cNvSpPr txBox="1"/>
           <p:nvPr/>
         </p:nvSpPr>

</xml_diff>